<commit_message>
feat(pptx): surgical set_notes_text for speaker notes
Patch only the notes slide part so agents can update speaker notes without touching slide XML; extend the demo deck and skill docs accordingly.

Co-authored-by: Cursor <cursoragent@cursor.com>
</commit_message>
<xml_diff>
--- a/demo/deck.pptx
+++ b/demo/deck.pptx
@@ -7,6 +7,38 @@
   </p:sldIdLst>
   <p:sldSz cx="9144000" cy="6858000"/>
 </p:presentation>
+</file>
+
+<file path=ppt/notesSlides/notesSlide1.xml><?xml version="1.0" encoding="utf-8"?>
+<p:notes xmlns:a="http://schemas.openxmlformats.org/drawingml/2006/main" xmlns:r="http://schemas.openxmlformats.org/officeDocument/2006/relationships" xmlns:p="http://schemas.openxmlformats.org/presentationml/2006/main">
+  <p:cSld>
+    <p:spTree>
+      <p:nvGrpSpPr>
+        <p:cNvPr id="1" name=""/>
+        <p:cNvGrpSpPr/>
+        <p:nvPr/>
+      </p:nvGrpSpPr>
+      <p:grpSpPr/>
+      <p:sp>
+        <p:nvSpPr>
+          <p:cNvPr id="2" name="Notes Placeholder 2"/>
+          <p:cNvSpPr/>
+          <p:nvPr/>
+        </p:nvSpPr>
+        <p:spPr/>
+        <p:txBody>
+          <a:bodyPr/>
+          <a:lstStyle/>
+          <a:p>
+            <a:r>
+              <a:t>Remind the room that NPS moved from 38 to 42 this quarter.</a:t>
+            </a:r>
+          </a:p>
+        </p:txBody>
+      </p:sp>
+    </p:spTree>
+  </p:cSld>
+</p:notes>
 </file>
 
 <file path=ppt/slides/slide1.xml><?xml version="1.0" encoding="utf-8"?>

</xml_diff>

<commit_message>
demo: apply Northstar pack verification fixes
Keep chart namespaces, PDF Priority as one field, and memo/deck geometry from the engine round-trip so inspect/read and the bake-off edits stay correct.

Co-authored-by: Cursor <cursoragent@cursor.com>
</commit_message>
<xml_diff>
--- a/demo/deck.pptx
+++ b/demo/deck.pptx
@@ -3838,8 +3838,8 @@
         </p:nvSpPr>
         <p:spPr>
           <a:xfrm>
-            <a:off x="566928" y="475488"/>
-            <a:ext cx="11057839" cy="201168"/>
+            <a:off x="566928" y="429768"/>
+            <a:ext cx="11057839" cy="182880"/>
           </a:xfrm>
           <a:prstGeom prst="rect">
             <a:avLst/>

</xml_diff>